<commit_message>
docs: restructure deployment and evaluation documentation
</commit_message>
<xml_diff>
--- a/docs/figures/dual-gpu-exploration.pptx
+++ b/docs/figures/dual-gpu-exploration.pptx
@@ -3125,7 +3125,7 @@
               </a:defRPr>
             </a:pPr>
             <a:r>
-              <a:t>The decision trail behind the retained dual-3090 profile</a:t>
+              <a:t>Dual-GPU Evaluation Overview</a:t>
             </a:r>
           </a:p>
         </p:txBody>
@@ -3164,7 +3164,7 @@
               </a:defRPr>
             </a:pPr>
             <a:r>
-              <a:t>Fit, client behavior, long-prefill decay, speculation, correctness and restoration each shaped the next experiment.</a:t>
+              <a:t>Engine compatibility, context scaling, speculative decoding and deployment validation</a:t>
             </a:r>
           </a:p>
         </p:txBody>
@@ -3248,7 +3248,7 @@
               </a:defRPr>
             </a:pPr>
             <a:r>
-              <a:t>01 / REAL WORKLOAD</a:t>
+              <a:t>01 / WORKLOAD</a:t>
             </a:r>
           </a:p>
         </p:txBody>
@@ -3287,7 +3287,7 @@
               </a:defRPr>
             </a:pPr>
             <a:r>
-              <a:t>Start from the client</a:t>
+              <a:t>Workload Definition</a:t>
             </a:r>
           </a:p>
         </p:txBody>
@@ -3326,7 +3326,7 @@
               </a:defRPr>
             </a:pPr>
             <a:r>
-              <a:t>Resume an existing task</a:t>
+              <a:t>Resumed Claude Code sessions</a:t>
             </a:r>
           </a:p>
           <a:p>
@@ -3342,7 +3342,7 @@
               </a:defRPr>
             </a:pPr>
             <a:r>
-              <a:t>Images, tools and follow-ups</a:t>
+              <a:t>Image and tool content</a:t>
             </a:r>
           </a:p>
           <a:p>
@@ -3358,7 +3358,7 @@
               </a:defRPr>
             </a:pPr>
             <a:r>
-              <a:t>Several sessions, one service</a:t>
+              <a:t>Shared inference service</a:t>
             </a:r>
           </a:p>
         </p:txBody>
@@ -3485,7 +3485,7 @@
               </a:defRPr>
             </a:pPr>
             <a:r>
-              <a:t>02 / FIT AND STARTUP</a:t>
+              <a:t>02 / GGUF</a:t>
             </a:r>
           </a:p>
         </p:txBody>
@@ -3524,7 +3524,7 @@
               </a:defRPr>
             </a:pPr>
             <a:r>
-              <a:t>Check the GGUF path</a:t>
+              <a:t>GGUF Compatibility</a:t>
             </a:r>
           </a:p>
         </p:txBody>
@@ -3595,7 +3595,7 @@
               </a:defRPr>
             </a:pPr>
             <a:r>
-              <a:t>Allocation + tiny-input logs</a:t>
+              <a:t>Allocation and timing records</a:t>
             </a:r>
           </a:p>
         </p:txBody>
@@ -3722,7 +3722,7 @@
               </a:defRPr>
             </a:pPr>
             <a:r>
-              <a:t>03 / LONG HISTORY</a:t>
+              <a:t>03 / PREFILL</a:t>
             </a:r>
           </a:p>
         </p:txBody>
@@ -3761,7 +3761,7 @@
               </a:defRPr>
             </a:pPr>
             <a:r>
-              <a:t>Measure long-prefill decay</a:t>
+              <a:t>Long-Context Prefill</a:t>
             </a:r>
           </a:p>
         </p:txBody>
@@ -3816,7 +3816,7 @@
               </a:defRPr>
             </a:pPr>
             <a:r>
-              <a:t>520k prefill slowed late</a:t>
+              <a:t>520k context scaling</a:t>
             </a:r>
           </a:p>
           <a:p>
@@ -3832,7 +3832,7 @@
               </a:defRPr>
             </a:pPr>
             <a:r>
-              <a:t>High hits, slow next-turn decode</a:t>
+              <a:t>Prefix reuse and decode</a:t>
             </a:r>
           </a:p>
         </p:txBody>
@@ -3959,7 +3959,7 @@
               </a:defRPr>
             </a:pPr>
             <a:r>
-              <a:t>04 / SERVING CHOICES</a:t>
+              <a:t>04 / PARALLELISM</a:t>
             </a:r>
           </a:p>
         </p:txBody>
@@ -3998,7 +3998,7 @@
               </a:defRPr>
             </a:pPr>
             <a:r>
-              <a:t>Probe layout and speculation</a:t>
+              <a:t>Parallelism and Drafting</a:t>
             </a:r>
           </a:p>
         </p:txBody>
@@ -4037,7 +4037,7 @@
               </a:defRPr>
             </a:pPr>
             <a:r>
-              <a:t>SGLang TP/PP; dynamic gate</a:t>
+              <a:t>SGLang TP/PP and chunking</a:t>
             </a:r>
           </a:p>
           <a:p>
@@ -4069,7 +4069,7 @@
               </a:defRPr>
             </a:pPr>
             <a:r>
-              <a:t>Precision and CUDA graph modes</a:t>
+              <a:t>Precision and CUDA graphs</a:t>
             </a:r>
           </a:p>
         </p:txBody>
@@ -4196,7 +4196,7 @@
               </a:defRPr>
             </a:pPr>
             <a:r>
-              <a:t>05 / LOCAL CONTROLS</a:t>
+              <a:t>05 / VERIFICATION</a:t>
             </a:r>
           </a:p>
         </p:txBody>
@@ -4235,7 +4235,7 @@
               </a:defRPr>
             </a:pPr>
             <a:r>
-              <a:t>Check matched candidates</a:t>
+              <a:t>Verification Kernels</a:t>
             </a:r>
           </a:p>
         </p:txBody>
@@ -4290,7 +4290,7 @@
               </a:defRPr>
             </a:pPr>
             <a:r>
-              <a:t>Legacy verification comparisons</a:t>
+              <a:t>Matched kernel comparisons</a:t>
             </a:r>
           </a:p>
           <a:p>
@@ -4306,7 +4306,7 @@
               </a:defRPr>
             </a:pPr>
             <a:r>
-              <a:t>Custom branch later retired</a:t>
+              <a:t>Archived experimental branch</a:t>
             </a:r>
           </a:p>
         </p:txBody>
@@ -4433,7 +4433,7 @@
               </a:defRPr>
             </a:pPr>
             <a:r>
-              <a:t>06 / RETAINED PROFILE</a:t>
+              <a:t>06 / CONFIGURATION</a:t>
             </a:r>
           </a:p>
         </p:txBody>
@@ -4472,7 +4472,7 @@
               </a:defRPr>
             </a:pPr>
             <a:r>
-              <a:t>Select public upstream code</a:t>
+              <a:t>Selected Runtime</a:t>
             </a:r>
           </a:p>
         </p:txBody>
@@ -4670,7 +4670,7 @@
               </a:defRPr>
             </a:pPr>
             <a:r>
-              <a:t>07 / RECOVERY EVIDENCE</a:t>
+              <a:t>07 / REPRODUCIBILITY</a:t>
             </a:r>
           </a:p>
         </p:txBody>
@@ -4709,7 +4709,7 @@
               </a:defRPr>
             </a:pPr>
             <a:r>
-              <a:t>Restore and reconstruct</a:t>
+              <a:t>Restoration Validation</a:t>
             </a:r>
           </a:p>
         </p:txBody>
@@ -4780,7 +4780,7 @@
               </a:defRPr>
             </a:pPr>
             <a:r>
-              <a:t>One text-prefix disk reload</a:t>
+              <a:t>Text-prefix disk recovery</a:t>
             </a:r>
           </a:p>
         </p:txBody>
@@ -4907,7 +4907,7 @@
               </a:defRPr>
             </a:pPr>
             <a:r>
-              <a:t>08 / REUSABLE DEPLOYMENT</a:t>
+              <a:t>08 / DEPLOYMENT</a:t>
             </a:r>
           </a:p>
         </p:txBody>
@@ -4946,7 +4946,7 @@
               </a:defRPr>
             </a:pPr>
             <a:r>
-              <a:t>Share a recoverable recipe</a:t>
+              <a:t>Client Integration</a:t>
             </a:r>
           </a:p>
         </p:txBody>
@@ -4985,7 +4985,7 @@
               </a:defRPr>
             </a:pPr>
             <a:r>
-              <a:t>Several clients, one server</a:t>
+              <a:t>Multiple clients, one server</a:t>
             </a:r>
           </a:p>
           <a:p>
@@ -5001,7 +5001,7 @@
               </a:defRPr>
             </a:pPr>
             <a:r>
-              <a:t>Disk-prefix reuse after reload</a:t>
+              <a:t>Persistent prefix storage</a:t>
             </a:r>
           </a:p>
           <a:p>
@@ -5017,7 +5017,7 @@
               </a:defRPr>
             </a:pPr>
             <a:r>
-              <a:t>Pinned setup + timing records</a:t>
+              <a:t>Pinned setup and measurements</a:t>
             </a:r>
           </a:p>
         </p:txBody>
@@ -5113,7 +5113,7 @@
               </a:defRPr>
             </a:pPr>
             <a:r>
-              <a:t>Prefill across a real 520k-token history</a:t>
+              <a:t>Long-Context Prefill Scaling</a:t>
             </a:r>
           </a:p>
         </p:txBody>
@@ -6617,7 +6617,7 @@
               </a:defRPr>
             </a:pPr>
             <a:r>
-              <a:t>Same first paper prompt, different SGLang layouts</a:t>
+              <a:t>SGLang Parallelism Evaluation</a:t>
             </a:r>
           </a:p>
         </p:txBody>
@@ -7551,7 +7551,7 @@
               </a:defRPr>
             </a:pPr>
             <a:r>
-              <a:t>Repeated measurements of the retained profile</a:t>
+              <a:t>Archive Restoration and Reconstruction</a:t>
             </a:r>
           </a:p>
         </p:txBody>

</xml_diff>